<commit_message>
Verify live Gemini and refresh pitch and demo evidence
</commit_message>
<xml_diff>
--- a/presentation/Qadam_ArcSolo_pitch_RU.pptx
+++ b/presentation/Qadam_ArcSolo_pitch_RU.pptx
@@ -594,7 +594,7 @@
           <a:p/>
           <a:p>
             <a:r>
-              <a:t>Мы не пытаемся скрыть границы прототипа. Сейчас данные покрывают пять районов, а пешее время оценивается по расстоянию с коэффициентом обхода. Следующий технический шаг — пешеходный граф с реальными входами и переходами. Следующий шаг по данным — проверенные описания и расписания от партнёров. Затем подключаем живую модель и оцениваем её на сценариях с пользователями. После этого имеет смысл добавлять события и групповое планирование, не размывая базовую полезность.</a:t>
+              <a:t>Мы не пытаемся скрыть границы прототипа. Сейчас данные покрывают пять районов, а пешее время оценивается по расстоянию с коэффициентом обхода. Следующий технический шаг — пешеходный граф с реальными входами и переходами. Следующий шаг по данным — проверенные описания и расписания от партнёров. Живую модель уже подключили; теперь оцениваем её на сценариях с пользователями. После этого имеет смысл добавлять события и групповое планирование, не размывая базовую полезность.</a:t>
             </a:r>
           </a:p>
         </p:txBody>
@@ -1050,7 +1050,7 @@
           <a:p/>
           <a:p>
             <a:r>
-              <a:t>Наш RAG начинается с реальных документов POI. Поиск сочетает BM25 и небольшой многоязычный словарь намерений. Затем строгие проверки исключают слишком далёкие места, неподходящие категории и визиты, которые не укладываются в известное расписание. Только после этого Gemini может выбрать идеи действий для найденных мест. Ответ ограничен разрешёнными идентификаторами и проверяется кодом. Это намеренно узкая генерация: модель не придумывает часы, адреса или новые заведения. Сейчас без ключа работает честно обозначенный шаблонный режим; живой вызов модели мы не выдаём за уже проверенный.</a:t>
+              <a:t>Наш RAG начинается с реальных документов POI. Поиск сочетает BM25 и небольшой многоязычный словарь намерений. Затем строгие проверки исключают слишком далёкие места, неподходящие категории и визиты, которые не укладываются в известное расписание. Только после этого Gemini может выбрать идеи действий для найденных мест. Ответ ограничен разрешёнными идентификаторами и проверяется кодом. Это намеренно узкая генерация: модель не придумывает часы, адреса или новые заведения. Живой вызов проверен локально и на размещённом демо. При ошибке провайдера остаётся честно обозначенный шаблонный режим.</a:t>
             </a:r>
           </a:p>
         </p:txBody>
@@ -5702,7 +5702,7 @@
               </a:defRPr>
             </a:pPr>
             <a:r>
-              <a:t>Живой Gemini, оценка полезности и устойчивости.</a:t>
+              <a:t>Оценка полезности и устойчивости на сценариях.</a:t>
             </a:r>
           </a:p>
         </p:txBody>
@@ -10630,7 +10630,7 @@
               </a:defRPr>
             </a:pPr>
             <a:r>
-              <a:t>Gemini*</a:t>
+              <a:t>Gemini</a:t>
             </a:r>
           </a:p>
         </p:txBody>
@@ -10966,7 +10966,7 @@
               </a:defRPr>
             </a:pPr>
             <a:r>
-              <a:t>* Без ключа работает явно обозначенный поиск с шаблонными идеями.</a:t>
+              <a:t>Живой Gemini проверен локально и на hosted-демо · 18.10.2026.</a:t>
             </a:r>
           </a:p>
         </p:txBody>
@@ -11033,7 +11033,7 @@
               </a:defRPr>
             </a:pPr>
             <a:r>
-              <a:t>Адаптер проверен на mock-ответах; живой вызов требует серверного ключа.</a:t>
+              <a:t>Ответ проходит проверку. При ошибке — явно обозначенные шаблонные идеи.</a:t>
             </a:r>
           </a:p>
         </p:txBody>

</xml_diff>

<commit_message>
Document public repository and evidence-based next improvements
</commit_message>
<xml_diff>
--- a/presentation/Qadam_ArcSolo_pitch_RU.pptx
+++ b/presentation/Qadam_ArcSolo_pitch_RU.pptx
@@ -671,7 +671,7 @@
           <a:p/>
           <a:p>
             <a:r>
-              <a:t>Сейчас есть пять районов и приблизительное время ходьбы. Следующий технический шаг — пешеходный граф с входами, переходами и барьерами. Следующий продуктовый шаг — наблюдать, как три–пять человек решают задачи в прототипе. Протокол уже готов; результаты ещё не получены. Затем проверим спрос и расширим местные факты. Новые функции будем выбирать по этим наблюдениям.</a:t>
+              <a:t>Следующие задачи опираются на конкретные пробелы. Проверка сложных запросов обнаружила ошибки составной длительности и точного отказа от категории. Исправим их и расширим независимые примеры. Затем добавим пешеходные пути с входами и переходами и тематические истории по источникам. Пользовательские сессии пока отложены. Инженерные проверки позволяют двигаться дальше, но не доказывают спрос или удобство для людей.</a:t>
             </a:r>
           </a:p>
         </p:txBody>
@@ -747,7 +747,7 @@
           <a:p/>
           <a:p>
             <a:r>
-              <a:t>Qadam превращает свободный час в небольшой понятный план. Пользователь видит реальные места, ограничения и возможность изменить решение. Работают сбор данных, интерфейс, генерация и проверки. Следующий шаг — испытать эту пользу с людьми. Спасибо! Готовы показать любой сценарий.</a:t>
+              <a:t>Qadam превращает свободный час в небольшой понятный план. Пользователь видит реальные места, ограничения и возможность изменить решение. Работают сбор данных, интерфейс, генерация и проверки. Мы продолжаем улучшать понимание запросов и маршруты. Спасибо! Готовы показать любой сценарий.</a:t>
             </a:r>
           </a:p>
         </p:txBody>
@@ -6692,7 +6692,7 @@
               </a:defRPr>
             </a:pPr>
             <a:r>
-              <a:t>Пока нет пользовательского пилота</a:t>
+              <a:t>Языковые крайние случаи</a:t>
             </a:r>
           </a:p>
         </p:txBody>
@@ -6782,7 +6782,7 @@
               </a:defRPr>
             </a:pPr>
             <a:r>
-              <a:t>Наблюдения, обратная связь и проверка спроса.</a:t>
+              <a:t>Уточнить длительность, отказ и контекст.</a:t>
             </a:r>
           </a:p>
         </p:txBody>
@@ -6827,7 +6827,7 @@
               </a:defRPr>
             </a:pPr>
             <a:r>
-              <a:t>Дальше: события, пешеходный граф, независимая проверка доступности.</a:t>
+              <a:t>Дальше: точнее понимать запрос, строить пути и связывать места в истории.</a:t>
             </a:r>
           </a:p>
         </p:txBody>
@@ -7247,7 +7247,7 @@
               </a:defRPr>
             </a:pPr>
             <a:r>
-              <a:t>Следующий шаг — пилот с реальными пользователями.</a:t>
+              <a:t>Дальше — точные запросы, пешеходные пути и истории.</a:t>
             </a:r>
           </a:p>
         </p:txBody>
@@ -7337,7 +7337,7 @@
               </a:defRPr>
             </a:pPr>
             <a:r>
-              <a:t>Репозиторий и hosted-демо пока приватные: для жюри нужен доступ или архив.</a:t>
+              <a:t>Код открыт на GitHub. Размещённое демо приватное; доступны локальный запуск и видео.</a:t>
             </a:r>
           </a:p>
         </p:txBody>

</xml_diff>